<commit_message>
Add IoU comparison slide to YOLO11 deck
New slide 10 (before the closing summary): a 4-row table contrasting
where each IoU variant is used — CIoU for box-regression loss and
positive-sample assignment vs plain IoU for mAP evaluation and NMS —
with source locations and the reason each is chosen. Rows are colour-
coded by family. pill() now takes a font arg so Chinese legend chips
render correctly.

Co-Authored-By: Claude Fable 5 <noreply@anthropic.com>
</commit_message>
<xml_diff>
--- a/docs/yolo11_modules.pptx
+++ b/docs/yolo11_modules.pptx
@@ -15,6 +15,7 @@
     <p:sldId id="263" r:id="rId14"/>
     <p:sldId id="264" r:id="rId15"/>
     <p:sldId id="265" r:id="rId16"/>
+    <p:sldId id="266" r:id="rId17"/>
   </p:sldIdLst>
   <p:sldSz cx="12191695" cy="6858000" type="screen4x3"/>
   <p:notesSz cx="6858000" cy="9144000"/>
@@ -3530,6 +3531,1778 @@
 </file>
 
 <file path=ppt/slides/slide10.xml><?xml version="1.0" encoding="utf-8"?>
+<p:sld xmlns:a="http://schemas.openxmlformats.org/drawingml/2006/main" xmlns:p="http://schemas.openxmlformats.org/presentationml/2006/main" xmlns:r="http://schemas.openxmlformats.org/officeDocument/2006/relationships">
+  <p:cSld>
+    <p:bg>
+      <p:bgPr>
+        <a:solidFill>
+          <a:srgbClr val="FFFFFF"/>
+        </a:solidFill>
+        <a:effectLst/>
+      </p:bgPr>
+    </p:bg>
+    <p:spTree>
+      <p:nvGrpSpPr>
+        <p:cNvPr id="1" name=""/>
+        <p:cNvGrpSpPr/>
+        <p:nvPr/>
+      </p:nvGrpSpPr>
+      <p:grpSpPr/>
+      <p:sp>
+        <p:nvSpPr>
+          <p:cNvPr id="2" name="TextBox 1"/>
+          <p:cNvSpPr txBox="1"/>
+          <p:nvPr/>
+        </p:nvSpPr>
+        <p:spPr>
+          <a:xfrm>
+            <a:off x="548640" y="411480"/>
+            <a:ext cx="11155680" cy="640080"/>
+          </a:xfrm>
+          <a:prstGeom prst="rect">
+            <a:avLst/>
+          </a:prstGeom>
+          <a:noFill/>
+        </p:spPr>
+        <p:txBody>
+          <a:bodyPr wrap="square" anchor="t" lIns="109728" rIns="109728" tIns="54864" bIns="54864">
+            <a:spAutoFit/>
+          </a:bodyPr>
+          <a:lstStyle/>
+          <a:p>
+            <a:pPr algn="l">
+              <a:spcBef>
+                <a:spcPts val="0"/>
+              </a:spcBef>
+              <a:spcAft>
+                <a:spcPts val="400"/>
+              </a:spcAft>
+            </a:pPr>
+            <a:r>
+              <a:rPr sz="3000" b="1" i="0">
+                <a:solidFill>
+                  <a:srgbClr val="0A2540"/>
+                </a:solidFill>
+                <a:latin typeface="Microsoft JhengHei"/>
+                <a:ea typeface="Microsoft JhengHei"/>
+                <a:cs typeface="Microsoft JhengHei"/>
+              </a:rPr>
+              <a:t>loss 的 IoU 與「判斷正確」的 IoU 一樣嗎？</a:t>
+            </a:r>
+          </a:p>
+        </p:txBody>
+      </p:sp>
+      <p:sp>
+        <p:nvSpPr>
+          <p:cNvPr id="3" name="TextBox 2"/>
+          <p:cNvSpPr txBox="1"/>
+          <p:nvPr/>
+        </p:nvSpPr>
+        <p:spPr>
+          <a:xfrm>
+            <a:off x="566928" y="1033271"/>
+            <a:ext cx="6949440" cy="365760"/>
+          </a:xfrm>
+          <a:prstGeom prst="rect">
+            <a:avLst/>
+          </a:prstGeom>
+          <a:noFill/>
+        </p:spPr>
+        <p:txBody>
+          <a:bodyPr wrap="square" anchor="t" lIns="109728" rIns="109728" tIns="54864" bIns="54864">
+            <a:spAutoFit/>
+          </a:bodyPr>
+          <a:lstStyle/>
+          <a:p>
+            <a:pPr algn="l">
+              <a:spcBef>
+                <a:spcPts val="0"/>
+              </a:spcBef>
+              <a:spcAft>
+                <a:spcPts val="400"/>
+              </a:spcAft>
+            </a:pPr>
+            <a:r>
+              <a:rPr sz="1400" b="1" i="0">
+                <a:solidFill>
+                  <a:srgbClr val="0A2540"/>
+                </a:solidFill>
+                <a:latin typeface="Microsoft JhengHei"/>
+                <a:ea typeface="Microsoft JhengHei"/>
+                <a:cs typeface="Microsoft JhengHei"/>
+              </a:rPr>
+              <a:t>答案：不一樣。</a:t>
+            </a:r>
+            <a:r>
+              <a:rPr sz="1400" b="0" i="0">
+                <a:solidFill>
+                  <a:srgbClr val="5A6B7B"/>
+                </a:solidFill>
+                <a:latin typeface="Microsoft JhengHei"/>
+                <a:ea typeface="Microsoft JhengHei"/>
+                <a:cs typeface="Microsoft JhengHei"/>
+              </a:rPr>
+              <a:t>訓練用 CIoU，評估 mAP 與 NMS 用純 IoU。</a:t>
+            </a:r>
+          </a:p>
+        </p:txBody>
+      </p:sp>
+      <p:sp>
+        <p:nvSpPr>
+          <p:cNvPr id="4" name="Rounded Rectangle 3"/>
+          <p:cNvSpPr/>
+          <p:nvPr/>
+        </p:nvSpPr>
+        <p:spPr>
+          <a:xfrm>
+            <a:off x="7818120" y="1005840"/>
+            <a:ext cx="1783080" cy="384048"/>
+          </a:xfrm>
+          <a:prstGeom prst="roundRect">
+            <a:avLst>
+              <a:gd name="adj" fmla="val 50000"/>
+            </a:avLst>
+          </a:prstGeom>
+          <a:solidFill>
+            <a:srgbClr val="1C7293"/>
+          </a:solidFill>
+          <a:ln>
+            <a:noFill/>
+          </a:ln>
+          <a:effectLst/>
+        </p:spPr>
+        <p:style>
+          <a:lnRef idx="1">
+            <a:schemeClr val="accent1"/>
+          </a:lnRef>
+          <a:fillRef idx="3">
+            <a:schemeClr val="accent1"/>
+          </a:fillRef>
+          <a:effectRef idx="2">
+            <a:schemeClr val="accent1"/>
+          </a:effectRef>
+          <a:fontRef idx="minor">
+            <a:schemeClr val="lt1"/>
+          </a:fontRef>
+        </p:style>
+        <p:txBody>
+          <a:bodyPr rtlCol="0" anchor="ctr" wrap="none" tIns="0" bIns="0"/>
+          <a:lstStyle/>
+          <a:p>
+            <a:pPr algn="ctr"/>
+            <a:r>
+              <a:rPr sz="1100" b="0" i="0">
+                <a:solidFill>
+                  <a:srgbClr val="FFFFFF"/>
+                </a:solidFill>
+                <a:latin typeface="Microsoft JhengHei"/>
+                <a:ea typeface="Microsoft JhengHei"/>
+                <a:cs typeface="Microsoft JhengHei"/>
+              </a:rPr>
+              <a:t>訓練 CIoU</a:t>
+            </a:r>
+          </a:p>
+        </p:txBody>
+      </p:sp>
+      <p:sp>
+        <p:nvSpPr>
+          <p:cNvPr id="5" name="Rounded Rectangle 4"/>
+          <p:cNvSpPr/>
+          <p:nvPr/>
+        </p:nvSpPr>
+        <p:spPr>
+          <a:xfrm>
+            <a:off x="9710928" y="1005840"/>
+            <a:ext cx="1920240" cy="384048"/>
+          </a:xfrm>
+          <a:prstGeom prst="roundRect">
+            <a:avLst>
+              <a:gd name="adj" fmla="val 50000"/>
+            </a:avLst>
+          </a:prstGeom>
+          <a:solidFill>
+            <a:srgbClr val="0A2540"/>
+          </a:solidFill>
+          <a:ln>
+            <a:noFill/>
+          </a:ln>
+          <a:effectLst/>
+        </p:spPr>
+        <p:style>
+          <a:lnRef idx="1">
+            <a:schemeClr val="accent1"/>
+          </a:lnRef>
+          <a:fillRef idx="3">
+            <a:schemeClr val="accent1"/>
+          </a:fillRef>
+          <a:effectRef idx="2">
+            <a:schemeClr val="accent1"/>
+          </a:effectRef>
+          <a:fontRef idx="minor">
+            <a:schemeClr val="lt1"/>
+          </a:fontRef>
+        </p:style>
+        <p:txBody>
+          <a:bodyPr rtlCol="0" anchor="ctr" wrap="none" tIns="0" bIns="0"/>
+          <a:lstStyle/>
+          <a:p>
+            <a:pPr algn="ctr"/>
+            <a:r>
+              <a:rPr sz="1100" b="0" i="0">
+                <a:solidFill>
+                  <a:srgbClr val="FFFFFF"/>
+                </a:solidFill>
+                <a:latin typeface="Microsoft JhengHei"/>
+                <a:ea typeface="Microsoft JhengHei"/>
+                <a:cs typeface="Microsoft JhengHei"/>
+              </a:rPr>
+              <a:t>評估 純 IoU</a:t>
+            </a:r>
+          </a:p>
+        </p:txBody>
+      </p:sp>
+      <p:sp>
+        <p:nvSpPr>
+          <p:cNvPr id="6" name="Rectangle 5"/>
+          <p:cNvSpPr/>
+          <p:nvPr/>
+        </p:nvSpPr>
+        <p:spPr>
+          <a:xfrm>
+            <a:off x="548640" y="1572768"/>
+            <a:ext cx="2468880" cy="457200"/>
+          </a:xfrm>
+          <a:prstGeom prst="rect">
+            <a:avLst/>
+          </a:prstGeom>
+          <a:solidFill>
+            <a:srgbClr val="0A2540"/>
+          </a:solidFill>
+          <a:ln w="6350">
+            <a:solidFill>
+              <a:srgbClr val="C9D6E2"/>
+            </a:solidFill>
+          </a:ln>
+          <a:effectLst/>
+        </p:spPr>
+        <p:style>
+          <a:lnRef idx="1">
+            <a:schemeClr val="accent1"/>
+          </a:lnRef>
+          <a:fillRef idx="3">
+            <a:schemeClr val="accent1"/>
+          </a:fillRef>
+          <a:effectRef idx="2">
+            <a:schemeClr val="accent1"/>
+          </a:effectRef>
+          <a:fontRef idx="minor">
+            <a:schemeClr val="lt1"/>
+          </a:fontRef>
+        </p:style>
+        <p:txBody>
+          <a:bodyPr rtlCol="0" anchor="ctr" wrap="square" lIns="109728" rIns="109728" tIns="54864" bIns="54864"/>
+          <a:lstStyle/>
+          <a:p>
+            <a:pPr algn="l">
+              <a:lnSpc>
+                <a:spcPct val="100000"/>
+              </a:lnSpc>
+              <a:spcBef>
+                <a:spcPts val="0"/>
+              </a:spcBef>
+              <a:spcAft>
+                <a:spcPts val="0"/>
+              </a:spcAft>
+            </a:pPr>
+            <a:r>
+              <a:rPr sz="1250" b="1" i="0">
+                <a:solidFill>
+                  <a:srgbClr val="FFFFFF"/>
+                </a:solidFill>
+                <a:latin typeface="Microsoft JhengHei"/>
+                <a:ea typeface="Microsoft JhengHei"/>
+                <a:cs typeface="Microsoft JhengHei"/>
+              </a:rPr>
+              <a:t>用途</a:t>
+            </a:r>
+          </a:p>
+        </p:txBody>
+      </p:sp>
+      <p:sp>
+        <p:nvSpPr>
+          <p:cNvPr id="7" name="Rectangle 6"/>
+          <p:cNvSpPr/>
+          <p:nvPr/>
+        </p:nvSpPr>
+        <p:spPr>
+          <a:xfrm>
+            <a:off x="3017520" y="1572768"/>
+            <a:ext cx="1737360" cy="457200"/>
+          </a:xfrm>
+          <a:prstGeom prst="rect">
+            <a:avLst/>
+          </a:prstGeom>
+          <a:solidFill>
+            <a:srgbClr val="0A2540"/>
+          </a:solidFill>
+          <a:ln w="6350">
+            <a:solidFill>
+              <a:srgbClr val="C9D6E2"/>
+            </a:solidFill>
+          </a:ln>
+          <a:effectLst/>
+        </p:spPr>
+        <p:style>
+          <a:lnRef idx="1">
+            <a:schemeClr val="accent1"/>
+          </a:lnRef>
+          <a:fillRef idx="3">
+            <a:schemeClr val="accent1"/>
+          </a:fillRef>
+          <a:effectRef idx="2">
+            <a:schemeClr val="accent1"/>
+          </a:effectRef>
+          <a:fontRef idx="minor">
+            <a:schemeClr val="lt1"/>
+          </a:fontRef>
+        </p:style>
+        <p:txBody>
+          <a:bodyPr rtlCol="0" anchor="ctr" wrap="square" lIns="109728" rIns="109728" tIns="54864" bIns="54864"/>
+          <a:lstStyle/>
+          <a:p>
+            <a:pPr algn="ctr">
+              <a:lnSpc>
+                <a:spcPct val="100000"/>
+              </a:lnSpc>
+              <a:spcBef>
+                <a:spcPts val="0"/>
+              </a:spcBef>
+              <a:spcAft>
+                <a:spcPts val="0"/>
+              </a:spcAft>
+            </a:pPr>
+            <a:r>
+              <a:rPr sz="1250" b="1" i="0">
+                <a:solidFill>
+                  <a:srgbClr val="FFFFFF"/>
+                </a:solidFill>
+                <a:latin typeface="Microsoft JhengHei"/>
+                <a:ea typeface="Microsoft JhengHei"/>
+                <a:cs typeface="Microsoft JhengHei"/>
+              </a:rPr>
+              <a:t>哪種 IoU</a:t>
+            </a:r>
+          </a:p>
+        </p:txBody>
+      </p:sp>
+      <p:sp>
+        <p:nvSpPr>
+          <p:cNvPr id="8" name="Rectangle 7"/>
+          <p:cNvSpPr/>
+          <p:nvPr/>
+        </p:nvSpPr>
+        <p:spPr>
+          <a:xfrm>
+            <a:off x="4754879" y="1572768"/>
+            <a:ext cx="2286000" cy="457200"/>
+          </a:xfrm>
+          <a:prstGeom prst="rect">
+            <a:avLst/>
+          </a:prstGeom>
+          <a:solidFill>
+            <a:srgbClr val="0A2540"/>
+          </a:solidFill>
+          <a:ln w="6350">
+            <a:solidFill>
+              <a:srgbClr val="C9D6E2"/>
+            </a:solidFill>
+          </a:ln>
+          <a:effectLst/>
+        </p:spPr>
+        <p:style>
+          <a:lnRef idx="1">
+            <a:schemeClr val="accent1"/>
+          </a:lnRef>
+          <a:fillRef idx="3">
+            <a:schemeClr val="accent1"/>
+          </a:fillRef>
+          <a:effectRef idx="2">
+            <a:schemeClr val="accent1"/>
+          </a:effectRef>
+          <a:fontRef idx="minor">
+            <a:schemeClr val="lt1"/>
+          </a:fontRef>
+        </p:style>
+        <p:txBody>
+          <a:bodyPr rtlCol="0" anchor="ctr" wrap="square" lIns="109728" rIns="109728" tIns="54864" bIns="54864"/>
+          <a:lstStyle/>
+          <a:p>
+            <a:pPr algn="ctr">
+              <a:lnSpc>
+                <a:spcPct val="100000"/>
+              </a:lnSpc>
+              <a:spcBef>
+                <a:spcPts val="0"/>
+              </a:spcBef>
+              <a:spcAft>
+                <a:spcPts val="0"/>
+              </a:spcAft>
+            </a:pPr>
+            <a:r>
+              <a:rPr sz="1250" b="1" i="0">
+                <a:solidFill>
+                  <a:srgbClr val="FFFFFF"/>
+                </a:solidFill>
+                <a:latin typeface="Microsoft JhengHei"/>
+                <a:ea typeface="Microsoft JhengHei"/>
+                <a:cs typeface="Microsoft JhengHei"/>
+              </a:rPr>
+              <a:t>程式位置</a:t>
+            </a:r>
+          </a:p>
+        </p:txBody>
+      </p:sp>
+      <p:sp>
+        <p:nvSpPr>
+          <p:cNvPr id="9" name="Rectangle 8"/>
+          <p:cNvSpPr/>
+          <p:nvPr/>
+        </p:nvSpPr>
+        <p:spPr>
+          <a:xfrm>
+            <a:off x="7040879" y="1572768"/>
+            <a:ext cx="4572000" cy="457200"/>
+          </a:xfrm>
+          <a:prstGeom prst="rect">
+            <a:avLst/>
+          </a:prstGeom>
+          <a:solidFill>
+            <a:srgbClr val="0A2540"/>
+          </a:solidFill>
+          <a:ln w="6350">
+            <a:solidFill>
+              <a:srgbClr val="C9D6E2"/>
+            </a:solidFill>
+          </a:ln>
+          <a:effectLst/>
+        </p:spPr>
+        <p:style>
+          <a:lnRef idx="1">
+            <a:schemeClr val="accent1"/>
+          </a:lnRef>
+          <a:fillRef idx="3">
+            <a:schemeClr val="accent1"/>
+          </a:fillRef>
+          <a:effectRef idx="2">
+            <a:schemeClr val="accent1"/>
+          </a:effectRef>
+          <a:fontRef idx="minor">
+            <a:schemeClr val="lt1"/>
+          </a:fontRef>
+        </p:style>
+        <p:txBody>
+          <a:bodyPr rtlCol="0" anchor="ctr" wrap="square" lIns="109728" rIns="109728" tIns="54864" bIns="54864"/>
+          <a:lstStyle/>
+          <a:p>
+            <a:pPr algn="l">
+              <a:lnSpc>
+                <a:spcPct val="100000"/>
+              </a:lnSpc>
+              <a:spcBef>
+                <a:spcPts val="0"/>
+              </a:spcBef>
+              <a:spcAft>
+                <a:spcPts val="0"/>
+              </a:spcAft>
+            </a:pPr>
+            <a:r>
+              <a:rPr sz="1250" b="1" i="0">
+                <a:solidFill>
+                  <a:srgbClr val="FFFFFF"/>
+                </a:solidFill>
+                <a:latin typeface="Microsoft JhengHei"/>
+                <a:ea typeface="Microsoft JhengHei"/>
+                <a:cs typeface="Microsoft JhengHei"/>
+              </a:rPr>
+              <a:t>為什麼選這種</a:t>
+            </a:r>
+          </a:p>
+        </p:txBody>
+      </p:sp>
+      <p:sp>
+        <p:nvSpPr>
+          <p:cNvPr id="10" name="Rectangle 9"/>
+          <p:cNvSpPr/>
+          <p:nvPr/>
+        </p:nvSpPr>
+        <p:spPr>
+          <a:xfrm>
+            <a:off x="548640" y="2029967"/>
+            <a:ext cx="2468880" cy="658368"/>
+          </a:xfrm>
+          <a:prstGeom prst="rect">
+            <a:avLst/>
+          </a:prstGeom>
+          <a:solidFill>
+            <a:srgbClr val="E1EFEA"/>
+          </a:solidFill>
+          <a:ln w="6350">
+            <a:solidFill>
+              <a:srgbClr val="C9D6E2"/>
+            </a:solidFill>
+          </a:ln>
+          <a:effectLst/>
+        </p:spPr>
+        <p:style>
+          <a:lnRef idx="1">
+            <a:schemeClr val="accent1"/>
+          </a:lnRef>
+          <a:fillRef idx="3">
+            <a:schemeClr val="accent1"/>
+          </a:fillRef>
+          <a:effectRef idx="2">
+            <a:schemeClr val="accent1"/>
+          </a:effectRef>
+          <a:fontRef idx="minor">
+            <a:schemeClr val="lt1"/>
+          </a:fontRef>
+        </p:style>
+        <p:txBody>
+          <a:bodyPr rtlCol="0" anchor="ctr" wrap="square" lIns="109728" rIns="109728" tIns="54864" bIns="54864"/>
+          <a:lstStyle/>
+          <a:p>
+            <a:pPr algn="l">
+              <a:lnSpc>
+                <a:spcPct val="100000"/>
+              </a:lnSpc>
+              <a:spcBef>
+                <a:spcPts val="0"/>
+              </a:spcBef>
+              <a:spcAft>
+                <a:spcPts val="0"/>
+              </a:spcAft>
+            </a:pPr>
+            <a:r>
+              <a:rPr sz="1250" b="0" i="0">
+                <a:solidFill>
+                  <a:srgbClr val="1A2733"/>
+                </a:solidFill>
+                <a:latin typeface="Microsoft JhengHei"/>
+                <a:ea typeface="Microsoft JhengHei"/>
+                <a:cs typeface="Microsoft JhengHei"/>
+              </a:rPr>
+              <a:t>① 框回歸 loss</a:t>
+            </a:r>
+          </a:p>
+        </p:txBody>
+      </p:sp>
+      <p:sp>
+        <p:nvSpPr>
+          <p:cNvPr id="11" name="Rectangle 10"/>
+          <p:cNvSpPr/>
+          <p:nvPr/>
+        </p:nvSpPr>
+        <p:spPr>
+          <a:xfrm>
+            <a:off x="3017520" y="2029967"/>
+            <a:ext cx="1737360" cy="658368"/>
+          </a:xfrm>
+          <a:prstGeom prst="rect">
+            <a:avLst/>
+          </a:prstGeom>
+          <a:solidFill>
+            <a:srgbClr val="E1EFEA"/>
+          </a:solidFill>
+          <a:ln w="6350">
+            <a:solidFill>
+              <a:srgbClr val="C9D6E2"/>
+            </a:solidFill>
+          </a:ln>
+          <a:effectLst/>
+        </p:spPr>
+        <p:style>
+          <a:lnRef idx="1">
+            <a:schemeClr val="accent1"/>
+          </a:lnRef>
+          <a:fillRef idx="3">
+            <a:schemeClr val="accent1"/>
+          </a:fillRef>
+          <a:effectRef idx="2">
+            <a:schemeClr val="accent1"/>
+          </a:effectRef>
+          <a:fontRef idx="minor">
+            <a:schemeClr val="lt1"/>
+          </a:fontRef>
+        </p:style>
+        <p:txBody>
+          <a:bodyPr rtlCol="0" anchor="ctr" wrap="square" lIns="109728" rIns="109728" tIns="54864" bIns="54864"/>
+          <a:lstStyle/>
+          <a:p>
+            <a:pPr algn="ctr">
+              <a:lnSpc>
+                <a:spcPct val="100000"/>
+              </a:lnSpc>
+              <a:spcBef>
+                <a:spcPts val="0"/>
+              </a:spcBef>
+              <a:spcAft>
+                <a:spcPts val="0"/>
+              </a:spcAft>
+            </a:pPr>
+            <a:r>
+              <a:rPr sz="1250" b="1" i="0">
+                <a:solidFill>
+                  <a:srgbClr val="1C7293"/>
+                </a:solidFill>
+                <a:latin typeface="Microsoft JhengHei"/>
+                <a:ea typeface="Microsoft JhengHei"/>
+                <a:cs typeface="Microsoft JhengHei"/>
+              </a:rPr>
+              <a:t>CIoU</a:t>
+            </a:r>
+          </a:p>
+        </p:txBody>
+      </p:sp>
+      <p:sp>
+        <p:nvSpPr>
+          <p:cNvPr id="12" name="Rectangle 11"/>
+          <p:cNvSpPr/>
+          <p:nvPr/>
+        </p:nvSpPr>
+        <p:spPr>
+          <a:xfrm>
+            <a:off x="4754879" y="2029967"/>
+            <a:ext cx="2286000" cy="658368"/>
+          </a:xfrm>
+          <a:prstGeom prst="rect">
+            <a:avLst/>
+          </a:prstGeom>
+          <a:solidFill>
+            <a:srgbClr val="E1EFEA"/>
+          </a:solidFill>
+          <a:ln w="6350">
+            <a:solidFill>
+              <a:srgbClr val="C9D6E2"/>
+            </a:solidFill>
+          </a:ln>
+          <a:effectLst/>
+        </p:spPr>
+        <p:style>
+          <a:lnRef idx="1">
+            <a:schemeClr val="accent1"/>
+          </a:lnRef>
+          <a:fillRef idx="3">
+            <a:schemeClr val="accent1"/>
+          </a:fillRef>
+          <a:effectRef idx="2">
+            <a:schemeClr val="accent1"/>
+          </a:effectRef>
+          <a:fontRef idx="minor">
+            <a:schemeClr val="lt1"/>
+          </a:fontRef>
+        </p:style>
+        <p:txBody>
+          <a:bodyPr rtlCol="0" anchor="ctr" wrap="square" lIns="109728" rIns="109728" tIns="54864" bIns="54864"/>
+          <a:lstStyle/>
+          <a:p>
+            <a:pPr algn="ctr">
+              <a:lnSpc>
+                <a:spcPct val="100000"/>
+              </a:lnSpc>
+              <a:spcBef>
+                <a:spcPts val="0"/>
+              </a:spcBef>
+              <a:spcAft>
+                <a:spcPts val="0"/>
+              </a:spcAft>
+            </a:pPr>
+            <a:r>
+              <a:rPr sz="1150" b="0" i="0">
+                <a:solidFill>
+                  <a:srgbClr val="1A2733"/>
+                </a:solidFill>
+                <a:latin typeface="Consolas"/>
+                <a:ea typeface="Consolas"/>
+                <a:cs typeface="Consolas"/>
+              </a:rPr>
+              <a:t>loss.py:189</a:t>
+            </a:r>
+          </a:p>
+        </p:txBody>
+      </p:sp>
+      <p:sp>
+        <p:nvSpPr>
+          <p:cNvPr id="13" name="Rectangle 12"/>
+          <p:cNvSpPr/>
+          <p:nvPr/>
+        </p:nvSpPr>
+        <p:spPr>
+          <a:xfrm>
+            <a:off x="7040879" y="2029967"/>
+            <a:ext cx="4572000" cy="658368"/>
+          </a:xfrm>
+          <a:prstGeom prst="rect">
+            <a:avLst/>
+          </a:prstGeom>
+          <a:solidFill>
+            <a:srgbClr val="E1EFEA"/>
+          </a:solidFill>
+          <a:ln w="6350">
+            <a:solidFill>
+              <a:srgbClr val="C9D6E2"/>
+            </a:solidFill>
+          </a:ln>
+          <a:effectLst/>
+        </p:spPr>
+        <p:style>
+          <a:lnRef idx="1">
+            <a:schemeClr val="accent1"/>
+          </a:lnRef>
+          <a:fillRef idx="3">
+            <a:schemeClr val="accent1"/>
+          </a:fillRef>
+          <a:effectRef idx="2">
+            <a:schemeClr val="accent1"/>
+          </a:effectRef>
+          <a:fontRef idx="minor">
+            <a:schemeClr val="lt1"/>
+          </a:fontRef>
+        </p:style>
+        <p:txBody>
+          <a:bodyPr rtlCol="0" anchor="ctr" wrap="square" lIns="109728" rIns="109728" tIns="54864" bIns="54864"/>
+          <a:lstStyle/>
+          <a:p>
+            <a:pPr algn="l">
+              <a:lnSpc>
+                <a:spcPct val="100000"/>
+              </a:lnSpc>
+              <a:spcBef>
+                <a:spcPts val="0"/>
+              </a:spcBef>
+              <a:spcAft>
+                <a:spcPts val="0"/>
+              </a:spcAft>
+            </a:pPr>
+            <a:r>
+              <a:rPr sz="1250" b="0" i="0">
+                <a:solidFill>
+                  <a:srgbClr val="1A2733"/>
+                </a:solidFill>
+                <a:latin typeface="Microsoft JhengHei"/>
+                <a:ea typeface="Microsoft JhengHei"/>
+                <a:cs typeface="Microsoft JhengHei"/>
+              </a:rPr>
+              <a:t>要可微分；兩框零重疊時仍要有梯度，模型才學得動</a:t>
+            </a:r>
+          </a:p>
+        </p:txBody>
+      </p:sp>
+      <p:sp>
+        <p:nvSpPr>
+          <p:cNvPr id="14" name="Rectangle 13"/>
+          <p:cNvSpPr/>
+          <p:nvPr/>
+        </p:nvSpPr>
+        <p:spPr>
+          <a:xfrm>
+            <a:off x="548640" y="2688335"/>
+            <a:ext cx="2468880" cy="658368"/>
+          </a:xfrm>
+          <a:prstGeom prst="rect">
+            <a:avLst/>
+          </a:prstGeom>
+          <a:solidFill>
+            <a:srgbClr val="E1EFEA"/>
+          </a:solidFill>
+          <a:ln w="6350">
+            <a:solidFill>
+              <a:srgbClr val="C9D6E2"/>
+            </a:solidFill>
+          </a:ln>
+          <a:effectLst/>
+        </p:spPr>
+        <p:style>
+          <a:lnRef idx="1">
+            <a:schemeClr val="accent1"/>
+          </a:lnRef>
+          <a:fillRef idx="3">
+            <a:schemeClr val="accent1"/>
+          </a:fillRef>
+          <a:effectRef idx="2">
+            <a:schemeClr val="accent1"/>
+          </a:effectRef>
+          <a:fontRef idx="minor">
+            <a:schemeClr val="lt1"/>
+          </a:fontRef>
+        </p:style>
+        <p:txBody>
+          <a:bodyPr rtlCol="0" anchor="ctr" wrap="square" lIns="109728" rIns="109728" tIns="54864" bIns="54864"/>
+          <a:lstStyle/>
+          <a:p>
+            <a:pPr algn="l">
+              <a:lnSpc>
+                <a:spcPct val="100000"/>
+              </a:lnSpc>
+              <a:spcBef>
+                <a:spcPts val="0"/>
+              </a:spcBef>
+              <a:spcAft>
+                <a:spcPts val="0"/>
+              </a:spcAft>
+            </a:pPr>
+            <a:r>
+              <a:rPr sz="1250" b="0" i="0">
+                <a:solidFill>
+                  <a:srgbClr val="1A2733"/>
+                </a:solidFill>
+                <a:latin typeface="Microsoft JhengHei"/>
+                <a:ea typeface="Microsoft JhengHei"/>
+                <a:cs typeface="Microsoft JhengHei"/>
+              </a:rPr>
+              <a:t>② 正樣本分配</a:t>
+            </a:r>
+          </a:p>
+        </p:txBody>
+      </p:sp>
+      <p:sp>
+        <p:nvSpPr>
+          <p:cNvPr id="15" name="Rectangle 14"/>
+          <p:cNvSpPr/>
+          <p:nvPr/>
+        </p:nvSpPr>
+        <p:spPr>
+          <a:xfrm>
+            <a:off x="3017520" y="2688335"/>
+            <a:ext cx="1737360" cy="658368"/>
+          </a:xfrm>
+          <a:prstGeom prst="rect">
+            <a:avLst/>
+          </a:prstGeom>
+          <a:solidFill>
+            <a:srgbClr val="E1EFEA"/>
+          </a:solidFill>
+          <a:ln w="6350">
+            <a:solidFill>
+              <a:srgbClr val="C9D6E2"/>
+            </a:solidFill>
+          </a:ln>
+          <a:effectLst/>
+        </p:spPr>
+        <p:style>
+          <a:lnRef idx="1">
+            <a:schemeClr val="accent1"/>
+          </a:lnRef>
+          <a:fillRef idx="3">
+            <a:schemeClr val="accent1"/>
+          </a:fillRef>
+          <a:effectRef idx="2">
+            <a:schemeClr val="accent1"/>
+          </a:effectRef>
+          <a:fontRef idx="minor">
+            <a:schemeClr val="lt1"/>
+          </a:fontRef>
+        </p:style>
+        <p:txBody>
+          <a:bodyPr rtlCol="0" anchor="ctr" wrap="square" lIns="109728" rIns="109728" tIns="54864" bIns="54864"/>
+          <a:lstStyle/>
+          <a:p>
+            <a:pPr algn="ctr">
+              <a:lnSpc>
+                <a:spcPct val="100000"/>
+              </a:lnSpc>
+              <a:spcBef>
+                <a:spcPts val="0"/>
+              </a:spcBef>
+              <a:spcAft>
+                <a:spcPts val="0"/>
+              </a:spcAft>
+            </a:pPr>
+            <a:r>
+              <a:rPr sz="1250" b="1" i="0">
+                <a:solidFill>
+                  <a:srgbClr val="1C7293"/>
+                </a:solidFill>
+                <a:latin typeface="Microsoft JhengHei"/>
+                <a:ea typeface="Microsoft JhengHei"/>
+                <a:cs typeface="Microsoft JhengHei"/>
+              </a:rPr>
+              <a:t>CIoU</a:t>
+            </a:r>
+          </a:p>
+        </p:txBody>
+      </p:sp>
+      <p:sp>
+        <p:nvSpPr>
+          <p:cNvPr id="16" name="Rectangle 15"/>
+          <p:cNvSpPr/>
+          <p:nvPr/>
+        </p:nvSpPr>
+        <p:spPr>
+          <a:xfrm>
+            <a:off x="4754879" y="2688335"/>
+            <a:ext cx="2286000" cy="658368"/>
+          </a:xfrm>
+          <a:prstGeom prst="rect">
+            <a:avLst/>
+          </a:prstGeom>
+          <a:solidFill>
+            <a:srgbClr val="E1EFEA"/>
+          </a:solidFill>
+          <a:ln w="6350">
+            <a:solidFill>
+              <a:srgbClr val="C9D6E2"/>
+            </a:solidFill>
+          </a:ln>
+          <a:effectLst/>
+        </p:spPr>
+        <p:style>
+          <a:lnRef idx="1">
+            <a:schemeClr val="accent1"/>
+          </a:lnRef>
+          <a:fillRef idx="3">
+            <a:schemeClr val="accent1"/>
+          </a:fillRef>
+          <a:effectRef idx="2">
+            <a:schemeClr val="accent1"/>
+          </a:effectRef>
+          <a:fontRef idx="minor">
+            <a:schemeClr val="lt1"/>
+          </a:fontRef>
+        </p:style>
+        <p:txBody>
+          <a:bodyPr rtlCol="0" anchor="ctr" wrap="square" lIns="109728" rIns="109728" tIns="54864" bIns="54864"/>
+          <a:lstStyle/>
+          <a:p>
+            <a:pPr algn="ctr">
+              <a:lnSpc>
+                <a:spcPct val="100000"/>
+              </a:lnSpc>
+              <a:spcBef>
+                <a:spcPts val="0"/>
+              </a:spcBef>
+              <a:spcAft>
+                <a:spcPts val="0"/>
+              </a:spcAft>
+            </a:pPr>
+            <a:r>
+              <a:rPr sz="1150" b="0" i="0">
+                <a:solidFill>
+                  <a:srgbClr val="1A2733"/>
+                </a:solidFill>
+                <a:latin typeface="Consolas"/>
+                <a:ea typeface="Consolas"/>
+                <a:cs typeface="Consolas"/>
+              </a:rPr>
+              <a:t>tal.py:215</a:t>
+            </a:r>
+          </a:p>
+        </p:txBody>
+      </p:sp>
+      <p:sp>
+        <p:nvSpPr>
+          <p:cNvPr id="17" name="Rectangle 16"/>
+          <p:cNvSpPr/>
+          <p:nvPr/>
+        </p:nvSpPr>
+        <p:spPr>
+          <a:xfrm>
+            <a:off x="7040879" y="2688335"/>
+            <a:ext cx="4572000" cy="658368"/>
+          </a:xfrm>
+          <a:prstGeom prst="rect">
+            <a:avLst/>
+          </a:prstGeom>
+          <a:solidFill>
+            <a:srgbClr val="E1EFEA"/>
+          </a:solidFill>
+          <a:ln w="6350">
+            <a:solidFill>
+              <a:srgbClr val="C9D6E2"/>
+            </a:solidFill>
+          </a:ln>
+          <a:effectLst/>
+        </p:spPr>
+        <p:style>
+          <a:lnRef idx="1">
+            <a:schemeClr val="accent1"/>
+          </a:lnRef>
+          <a:fillRef idx="3">
+            <a:schemeClr val="accent1"/>
+          </a:fillRef>
+          <a:effectRef idx="2">
+            <a:schemeClr val="accent1"/>
+          </a:effectRef>
+          <a:fontRef idx="minor">
+            <a:schemeClr val="lt1"/>
+          </a:fontRef>
+        </p:style>
+        <p:txBody>
+          <a:bodyPr rtlCol="0" anchor="ctr" wrap="square" lIns="109728" rIns="109728" tIns="54864" bIns="54864"/>
+          <a:lstStyle/>
+          <a:p>
+            <a:pPr algn="l">
+              <a:lnSpc>
+                <a:spcPct val="100000"/>
+              </a:lnSpc>
+              <a:spcBef>
+                <a:spcPts val="0"/>
+              </a:spcBef>
+              <a:spcAft>
+                <a:spcPts val="0"/>
+              </a:spcAft>
+            </a:pPr>
+            <a:r>
+              <a:rPr sz="1250" b="0" i="0">
+                <a:solidFill>
+                  <a:srgbClr val="1A2733"/>
+                </a:solidFill>
+                <a:latin typeface="Microsoft JhengHei"/>
+                <a:ea typeface="Microsoft JhengHei"/>
+                <a:cs typeface="Microsoft JhengHei"/>
+              </a:rPr>
+              <a:t>當「框品質」分數，決定哪個 anchor 配哪個 GT</a:t>
+            </a:r>
+          </a:p>
+        </p:txBody>
+      </p:sp>
+      <p:sp>
+        <p:nvSpPr>
+          <p:cNvPr id="18" name="Rectangle 17"/>
+          <p:cNvSpPr/>
+          <p:nvPr/>
+        </p:nvSpPr>
+        <p:spPr>
+          <a:xfrm>
+            <a:off x="548640" y="3346703"/>
+            <a:ext cx="2468880" cy="658368"/>
+          </a:xfrm>
+          <a:prstGeom prst="rect">
+            <a:avLst/>
+          </a:prstGeom>
+          <a:solidFill>
+            <a:srgbClr val="E9EEF5"/>
+          </a:solidFill>
+          <a:ln w="6350">
+            <a:solidFill>
+              <a:srgbClr val="C9D6E2"/>
+            </a:solidFill>
+          </a:ln>
+          <a:effectLst/>
+        </p:spPr>
+        <p:style>
+          <a:lnRef idx="1">
+            <a:schemeClr val="accent1"/>
+          </a:lnRef>
+          <a:fillRef idx="3">
+            <a:schemeClr val="accent1"/>
+          </a:fillRef>
+          <a:effectRef idx="2">
+            <a:schemeClr val="accent1"/>
+          </a:effectRef>
+          <a:fontRef idx="minor">
+            <a:schemeClr val="lt1"/>
+          </a:fontRef>
+        </p:style>
+        <p:txBody>
+          <a:bodyPr rtlCol="0" anchor="ctr" wrap="square" lIns="109728" rIns="109728" tIns="54864" bIns="54864"/>
+          <a:lstStyle/>
+          <a:p>
+            <a:pPr algn="l">
+              <a:lnSpc>
+                <a:spcPct val="100000"/>
+              </a:lnSpc>
+              <a:spcBef>
+                <a:spcPts val="0"/>
+              </a:spcBef>
+              <a:spcAft>
+                <a:spcPts val="0"/>
+              </a:spcAft>
+            </a:pPr>
+            <a:r>
+              <a:rPr sz="1250" b="0" i="0">
+                <a:solidFill>
+                  <a:srgbClr val="1A2733"/>
+                </a:solidFill>
+                <a:latin typeface="Microsoft JhengHei"/>
+                <a:ea typeface="Microsoft JhengHei"/>
+                <a:cs typeface="Microsoft JhengHei"/>
+              </a:rPr>
+              <a:t>③ 驗證 / mAP 判定</a:t>
+            </a:r>
+          </a:p>
+        </p:txBody>
+      </p:sp>
+      <p:sp>
+        <p:nvSpPr>
+          <p:cNvPr id="19" name="Rectangle 18"/>
+          <p:cNvSpPr/>
+          <p:nvPr/>
+        </p:nvSpPr>
+        <p:spPr>
+          <a:xfrm>
+            <a:off x="3017520" y="3346703"/>
+            <a:ext cx="1737360" cy="658368"/>
+          </a:xfrm>
+          <a:prstGeom prst="rect">
+            <a:avLst/>
+          </a:prstGeom>
+          <a:solidFill>
+            <a:srgbClr val="E9EEF5"/>
+          </a:solidFill>
+          <a:ln w="6350">
+            <a:solidFill>
+              <a:srgbClr val="C9D6E2"/>
+            </a:solidFill>
+          </a:ln>
+          <a:effectLst/>
+        </p:spPr>
+        <p:style>
+          <a:lnRef idx="1">
+            <a:schemeClr val="accent1"/>
+          </a:lnRef>
+          <a:fillRef idx="3">
+            <a:schemeClr val="accent1"/>
+          </a:fillRef>
+          <a:effectRef idx="2">
+            <a:schemeClr val="accent1"/>
+          </a:effectRef>
+          <a:fontRef idx="minor">
+            <a:schemeClr val="lt1"/>
+          </a:fontRef>
+        </p:style>
+        <p:txBody>
+          <a:bodyPr rtlCol="0" anchor="ctr" wrap="square" lIns="109728" rIns="109728" tIns="54864" bIns="54864"/>
+          <a:lstStyle/>
+          <a:p>
+            <a:pPr algn="ctr">
+              <a:lnSpc>
+                <a:spcPct val="100000"/>
+              </a:lnSpc>
+              <a:spcBef>
+                <a:spcPts val="0"/>
+              </a:spcBef>
+              <a:spcAft>
+                <a:spcPts val="0"/>
+              </a:spcAft>
+            </a:pPr>
+            <a:r>
+              <a:rPr sz="1250" b="1" i="0">
+                <a:solidFill>
+                  <a:srgbClr val="0A2540"/>
+                </a:solidFill>
+                <a:latin typeface="Microsoft JhengHei"/>
+                <a:ea typeface="Microsoft JhengHei"/>
+                <a:cs typeface="Microsoft JhengHei"/>
+              </a:rPr>
+              <a:t>純 IoU</a:t>
+            </a:r>
+          </a:p>
+        </p:txBody>
+      </p:sp>
+      <p:sp>
+        <p:nvSpPr>
+          <p:cNvPr id="20" name="Rectangle 19"/>
+          <p:cNvSpPr/>
+          <p:nvPr/>
+        </p:nvSpPr>
+        <p:spPr>
+          <a:xfrm>
+            <a:off x="4754879" y="3346703"/>
+            <a:ext cx="2286000" cy="658368"/>
+          </a:xfrm>
+          <a:prstGeom prst="rect">
+            <a:avLst/>
+          </a:prstGeom>
+          <a:solidFill>
+            <a:srgbClr val="E9EEF5"/>
+          </a:solidFill>
+          <a:ln w="6350">
+            <a:solidFill>
+              <a:srgbClr val="C9D6E2"/>
+            </a:solidFill>
+          </a:ln>
+          <a:effectLst/>
+        </p:spPr>
+        <p:style>
+          <a:lnRef idx="1">
+            <a:schemeClr val="accent1"/>
+          </a:lnRef>
+          <a:fillRef idx="3">
+            <a:schemeClr val="accent1"/>
+          </a:fillRef>
+          <a:effectRef idx="2">
+            <a:schemeClr val="accent1"/>
+          </a:effectRef>
+          <a:fontRef idx="minor">
+            <a:schemeClr val="lt1"/>
+          </a:fontRef>
+        </p:style>
+        <p:txBody>
+          <a:bodyPr rtlCol="0" anchor="ctr" wrap="square" lIns="109728" rIns="109728" tIns="54864" bIns="54864"/>
+          <a:lstStyle/>
+          <a:p>
+            <a:pPr algn="ctr">
+              <a:lnSpc>
+                <a:spcPct val="100000"/>
+              </a:lnSpc>
+              <a:spcBef>
+                <a:spcPts val="0"/>
+              </a:spcBef>
+              <a:spcAft>
+                <a:spcPts val="0"/>
+              </a:spcAft>
+            </a:pPr>
+            <a:r>
+              <a:rPr sz="1150" b="0" i="0">
+                <a:solidFill>
+                  <a:srgbClr val="1A2733"/>
+                </a:solidFill>
+                <a:latin typeface="Consolas"/>
+                <a:ea typeface="Consolas"/>
+                <a:cs typeface="Consolas"/>
+              </a:rPr>
+              <a:t>metrics.py:454</a:t>
+            </a:r>
+          </a:p>
+        </p:txBody>
+      </p:sp>
+      <p:sp>
+        <p:nvSpPr>
+          <p:cNvPr id="21" name="Rectangle 20"/>
+          <p:cNvSpPr/>
+          <p:nvPr/>
+        </p:nvSpPr>
+        <p:spPr>
+          <a:xfrm>
+            <a:off x="7040879" y="3346703"/>
+            <a:ext cx="4572000" cy="658368"/>
+          </a:xfrm>
+          <a:prstGeom prst="rect">
+            <a:avLst/>
+          </a:prstGeom>
+          <a:solidFill>
+            <a:srgbClr val="E9EEF5"/>
+          </a:solidFill>
+          <a:ln w="6350">
+            <a:solidFill>
+              <a:srgbClr val="C9D6E2"/>
+            </a:solidFill>
+          </a:ln>
+          <a:effectLst/>
+        </p:spPr>
+        <p:style>
+          <a:lnRef idx="1">
+            <a:schemeClr val="accent1"/>
+          </a:lnRef>
+          <a:fillRef idx="3">
+            <a:schemeClr val="accent1"/>
+          </a:fillRef>
+          <a:effectRef idx="2">
+            <a:schemeClr val="accent1"/>
+          </a:effectRef>
+          <a:fontRef idx="minor">
+            <a:schemeClr val="lt1"/>
+          </a:fontRef>
+        </p:style>
+        <p:txBody>
+          <a:bodyPr rtlCol="0" anchor="ctr" wrap="square" lIns="109728" rIns="109728" tIns="54864" bIns="54864"/>
+          <a:lstStyle/>
+          <a:p>
+            <a:pPr algn="l">
+              <a:lnSpc>
+                <a:spcPct val="100000"/>
+              </a:lnSpc>
+              <a:spcBef>
+                <a:spcPts val="0"/>
+              </a:spcBef>
+              <a:spcAft>
+                <a:spcPts val="0"/>
+              </a:spcAft>
+            </a:pPr>
+            <a:r>
+              <a:rPr sz="1250" b="0" i="0">
+                <a:solidFill>
+                  <a:srgbClr val="1A2733"/>
+                </a:solidFill>
+                <a:latin typeface="Microsoft JhengHei"/>
+                <a:ea typeface="Microsoft JhengHei"/>
+                <a:cs typeface="Microsoft JhengHei"/>
+              </a:rPr>
+              <a:t>要公平、標準（COCO 慣例），門檻 0.5–0.95</a:t>
+            </a:r>
+          </a:p>
+        </p:txBody>
+      </p:sp>
+      <p:sp>
+        <p:nvSpPr>
+          <p:cNvPr id="22" name="Rectangle 21"/>
+          <p:cNvSpPr/>
+          <p:nvPr/>
+        </p:nvSpPr>
+        <p:spPr>
+          <a:xfrm>
+            <a:off x="548640" y="4005072"/>
+            <a:ext cx="2468880" cy="658368"/>
+          </a:xfrm>
+          <a:prstGeom prst="rect">
+            <a:avLst/>
+          </a:prstGeom>
+          <a:solidFill>
+            <a:srgbClr val="E9EEF5"/>
+          </a:solidFill>
+          <a:ln w="6350">
+            <a:solidFill>
+              <a:srgbClr val="C9D6E2"/>
+            </a:solidFill>
+          </a:ln>
+          <a:effectLst/>
+        </p:spPr>
+        <p:style>
+          <a:lnRef idx="1">
+            <a:schemeClr val="accent1"/>
+          </a:lnRef>
+          <a:fillRef idx="3">
+            <a:schemeClr val="accent1"/>
+          </a:fillRef>
+          <a:effectRef idx="2">
+            <a:schemeClr val="accent1"/>
+          </a:effectRef>
+          <a:fontRef idx="minor">
+            <a:schemeClr val="lt1"/>
+          </a:fontRef>
+        </p:style>
+        <p:txBody>
+          <a:bodyPr rtlCol="0" anchor="ctr" wrap="square" lIns="109728" rIns="109728" tIns="54864" bIns="54864"/>
+          <a:lstStyle/>
+          <a:p>
+            <a:pPr algn="l">
+              <a:lnSpc>
+                <a:spcPct val="100000"/>
+              </a:lnSpc>
+              <a:spcBef>
+                <a:spcPts val="0"/>
+              </a:spcBef>
+              <a:spcAft>
+                <a:spcPts val="0"/>
+              </a:spcAft>
+            </a:pPr>
+            <a:r>
+              <a:rPr sz="1250" b="0" i="0">
+                <a:solidFill>
+                  <a:srgbClr val="1A2733"/>
+                </a:solidFill>
+                <a:latin typeface="Microsoft JhengHei"/>
+                <a:ea typeface="Microsoft JhengHei"/>
+                <a:cs typeface="Microsoft JhengHei"/>
+              </a:rPr>
+              <a:t>④ NMS 去重</a:t>
+            </a:r>
+          </a:p>
+        </p:txBody>
+      </p:sp>
+      <p:sp>
+        <p:nvSpPr>
+          <p:cNvPr id="23" name="Rectangle 22"/>
+          <p:cNvSpPr/>
+          <p:nvPr/>
+        </p:nvSpPr>
+        <p:spPr>
+          <a:xfrm>
+            <a:off x="3017520" y="4005072"/>
+            <a:ext cx="1737360" cy="658368"/>
+          </a:xfrm>
+          <a:prstGeom prst="rect">
+            <a:avLst/>
+          </a:prstGeom>
+          <a:solidFill>
+            <a:srgbClr val="E9EEF5"/>
+          </a:solidFill>
+          <a:ln w="6350">
+            <a:solidFill>
+              <a:srgbClr val="C9D6E2"/>
+            </a:solidFill>
+          </a:ln>
+          <a:effectLst/>
+        </p:spPr>
+        <p:style>
+          <a:lnRef idx="1">
+            <a:schemeClr val="accent1"/>
+          </a:lnRef>
+          <a:fillRef idx="3">
+            <a:schemeClr val="accent1"/>
+          </a:fillRef>
+          <a:effectRef idx="2">
+            <a:schemeClr val="accent1"/>
+          </a:effectRef>
+          <a:fontRef idx="minor">
+            <a:schemeClr val="lt1"/>
+          </a:fontRef>
+        </p:style>
+        <p:txBody>
+          <a:bodyPr rtlCol="0" anchor="ctr" wrap="square" lIns="109728" rIns="109728" tIns="54864" bIns="54864"/>
+          <a:lstStyle/>
+          <a:p>
+            <a:pPr algn="ctr">
+              <a:lnSpc>
+                <a:spcPct val="100000"/>
+              </a:lnSpc>
+              <a:spcBef>
+                <a:spcPts val="0"/>
+              </a:spcBef>
+              <a:spcAft>
+                <a:spcPts val="0"/>
+              </a:spcAft>
+            </a:pPr>
+            <a:r>
+              <a:rPr sz="1250" b="1" i="0">
+                <a:solidFill>
+                  <a:srgbClr val="0A2540"/>
+                </a:solidFill>
+                <a:latin typeface="Microsoft JhengHei"/>
+                <a:ea typeface="Microsoft JhengHei"/>
+                <a:cs typeface="Microsoft JhengHei"/>
+              </a:rPr>
+              <a:t>純 IoU</a:t>
+            </a:r>
+          </a:p>
+        </p:txBody>
+      </p:sp>
+      <p:sp>
+        <p:nvSpPr>
+          <p:cNvPr id="24" name="Rectangle 23"/>
+          <p:cNvSpPr/>
+          <p:nvPr/>
+        </p:nvSpPr>
+        <p:spPr>
+          <a:xfrm>
+            <a:off x="4754879" y="4005072"/>
+            <a:ext cx="2286000" cy="658368"/>
+          </a:xfrm>
+          <a:prstGeom prst="rect">
+            <a:avLst/>
+          </a:prstGeom>
+          <a:solidFill>
+            <a:srgbClr val="E9EEF5"/>
+          </a:solidFill>
+          <a:ln w="6350">
+            <a:solidFill>
+              <a:srgbClr val="C9D6E2"/>
+            </a:solidFill>
+          </a:ln>
+          <a:effectLst/>
+        </p:spPr>
+        <p:style>
+          <a:lnRef idx="1">
+            <a:schemeClr val="accent1"/>
+          </a:lnRef>
+          <a:fillRef idx="3">
+            <a:schemeClr val="accent1"/>
+          </a:fillRef>
+          <a:effectRef idx="2">
+            <a:schemeClr val="accent1"/>
+          </a:effectRef>
+          <a:fontRef idx="minor">
+            <a:schemeClr val="lt1"/>
+          </a:fontRef>
+        </p:style>
+        <p:txBody>
+          <a:bodyPr rtlCol="0" anchor="ctr" wrap="square" lIns="109728" rIns="109728" tIns="54864" bIns="54864"/>
+          <a:lstStyle/>
+          <a:p>
+            <a:pPr algn="ctr">
+              <a:lnSpc>
+                <a:spcPct val="100000"/>
+              </a:lnSpc>
+              <a:spcBef>
+                <a:spcPts val="0"/>
+              </a:spcBef>
+              <a:spcAft>
+                <a:spcPts val="0"/>
+              </a:spcAft>
+            </a:pPr>
+            <a:r>
+              <a:rPr sz="1150" b="0" i="0">
+                <a:solidFill>
+                  <a:srgbClr val="1A2733"/>
+                </a:solidFill>
+                <a:latin typeface="Consolas"/>
+                <a:ea typeface="Consolas"/>
+                <a:cs typeface="Consolas"/>
+              </a:rPr>
+              <a:t>iou = 0.7</a:t>
+            </a:r>
+          </a:p>
+        </p:txBody>
+      </p:sp>
+      <p:sp>
+        <p:nvSpPr>
+          <p:cNvPr id="25" name="Rectangle 24"/>
+          <p:cNvSpPr/>
+          <p:nvPr/>
+        </p:nvSpPr>
+        <p:spPr>
+          <a:xfrm>
+            <a:off x="7040879" y="4005072"/>
+            <a:ext cx="4572000" cy="658368"/>
+          </a:xfrm>
+          <a:prstGeom prst="rect">
+            <a:avLst/>
+          </a:prstGeom>
+          <a:solidFill>
+            <a:srgbClr val="E9EEF5"/>
+          </a:solidFill>
+          <a:ln w="6350">
+            <a:solidFill>
+              <a:srgbClr val="C9D6E2"/>
+            </a:solidFill>
+          </a:ln>
+          <a:effectLst/>
+        </p:spPr>
+        <p:style>
+          <a:lnRef idx="1">
+            <a:schemeClr val="accent1"/>
+          </a:lnRef>
+          <a:fillRef idx="3">
+            <a:schemeClr val="accent1"/>
+          </a:fillRef>
+          <a:effectRef idx="2">
+            <a:schemeClr val="accent1"/>
+          </a:effectRef>
+          <a:fontRef idx="minor">
+            <a:schemeClr val="lt1"/>
+          </a:fontRef>
+        </p:style>
+        <p:txBody>
+          <a:bodyPr rtlCol="0" anchor="ctr" wrap="square" lIns="109728" rIns="109728" tIns="54864" bIns="54864"/>
+          <a:lstStyle/>
+          <a:p>
+            <a:pPr algn="l">
+              <a:lnSpc>
+                <a:spcPct val="100000"/>
+              </a:lnSpc>
+              <a:spcBef>
+                <a:spcPts val="0"/>
+              </a:spcBef>
+              <a:spcAft>
+                <a:spcPts val="0"/>
+              </a:spcAft>
+            </a:pPr>
+            <a:r>
+              <a:rPr sz="1250" b="0" i="0">
+                <a:solidFill>
+                  <a:srgbClr val="1A2733"/>
+                </a:solidFill>
+                <a:latin typeface="Microsoft JhengHei"/>
+                <a:ea typeface="Microsoft JhengHei"/>
+                <a:cs typeface="Microsoft JhengHei"/>
+              </a:rPr>
+              <a:t>只需衡量重疊程度，移除重複的框</a:t>
+            </a:r>
+          </a:p>
+        </p:txBody>
+      </p:sp>
+      <p:sp>
+        <p:nvSpPr>
+          <p:cNvPr id="26" name="Rounded Rectangle 25"/>
+          <p:cNvSpPr/>
+          <p:nvPr/>
+        </p:nvSpPr>
+        <p:spPr>
+          <a:xfrm>
+            <a:off x="548640" y="4828032"/>
+            <a:ext cx="11064240" cy="1554480"/>
+          </a:xfrm>
+          <a:prstGeom prst="roundRect">
+            <a:avLst>
+              <a:gd name="adj" fmla="val 6000"/>
+            </a:avLst>
+          </a:prstGeom>
+          <a:solidFill>
+            <a:srgbClr val="EEF3F8"/>
+          </a:solidFill>
+          <a:ln>
+            <a:noFill/>
+          </a:ln>
+          <a:effectLst/>
+        </p:spPr>
+        <p:style>
+          <a:lnRef idx="1">
+            <a:schemeClr val="accent1"/>
+          </a:lnRef>
+          <a:fillRef idx="3">
+            <a:schemeClr val="accent1"/>
+          </a:fillRef>
+          <a:effectRef idx="2">
+            <a:schemeClr val="accent1"/>
+          </a:effectRef>
+          <a:fontRef idx="minor">
+            <a:schemeClr val="lt1"/>
+          </a:fontRef>
+        </p:style>
+        <p:txBody>
+          <a:bodyPr rtlCol="0" anchor="t" wrap="square" lIns="109728" rIns="109728" tIns="54864" bIns="54864"/>
+          <a:lstStyle/>
+          <a:p>
+            <a:pPr algn="l">
+              <a:spcBef>
+                <a:spcPts val="0"/>
+              </a:spcBef>
+              <a:spcAft>
+                <a:spcPts val="800"/>
+              </a:spcAft>
+            </a:pPr>
+            <a:r>
+              <a:rPr sz="1600" b="1" i="0">
+                <a:solidFill>
+                  <a:srgbClr val="1C7293"/>
+                </a:solidFill>
+                <a:latin typeface="Microsoft JhengHei"/>
+                <a:ea typeface="Microsoft JhengHei"/>
+                <a:cs typeface="Microsoft JhengHei"/>
+              </a:rPr>
+              <a:t>關鍵差別：為什麼不能混用</a:t>
+            </a:r>
+          </a:p>
+          <a:p>
+            <a:pPr algn="l">
+              <a:spcBef>
+                <a:spcPts val="0"/>
+              </a:spcBef>
+              <a:spcAft>
+                <a:spcPts val="700"/>
+              </a:spcAft>
+            </a:pPr>
+            <a:r>
+              <a:rPr sz="1450" b="1" i="0">
+                <a:solidFill>
+                  <a:srgbClr val="0A2540"/>
+                </a:solidFill>
+                <a:latin typeface="Microsoft JhengHei"/>
+                <a:ea typeface="Microsoft JhengHei"/>
+                <a:cs typeface="Microsoft JhengHei"/>
+              </a:rPr>
+              <a:t>純 IoU = 交集 / 聯集</a:t>
+            </a:r>
+            <a:r>
+              <a:rPr sz="1350" b="0" i="0">
+                <a:solidFill>
+                  <a:srgbClr val="1A2733"/>
+                </a:solidFill>
+                <a:latin typeface="Microsoft JhengHei"/>
+                <a:ea typeface="Microsoft JhengHei"/>
+                <a:cs typeface="Microsoft JhengHei"/>
+              </a:rPr>
+              <a:t>　兩框沒重疊就 = 0，梯度也 = 0</a:t>
+            </a:r>
+          </a:p>
+          <a:p>
+            <a:pPr algn="l">
+              <a:spcBef>
+                <a:spcPts val="0"/>
+              </a:spcBef>
+              <a:spcAft>
+                <a:spcPts val="700"/>
+              </a:spcAft>
+            </a:pPr>
+            <a:r>
+              <a:rPr sz="1450" b="1" i="0">
+                <a:solidFill>
+                  <a:srgbClr val="0A2540"/>
+                </a:solidFill>
+                <a:latin typeface="Microsoft JhengHei"/>
+                <a:ea typeface="Microsoft JhengHei"/>
+                <a:cs typeface="Microsoft JhengHei"/>
+              </a:rPr>
+              <a:t>CIoU = IoU − 中心距離懲罰 − 長寬比懲罰</a:t>
+            </a:r>
+            <a:r>
+              <a:rPr sz="1350" b="0" i="0">
+                <a:solidFill>
+                  <a:srgbClr val="1A2733"/>
+                </a:solidFill>
+                <a:latin typeface="Microsoft JhengHei"/>
+                <a:ea typeface="Microsoft JhengHei"/>
+                <a:cs typeface="Microsoft JhengHei"/>
+              </a:rPr>
+              <a:t>　零重疊時仍有梯度可學</a:t>
+            </a:r>
+          </a:p>
+          <a:p>
+            <a:pPr algn="l">
+              <a:spcBef>
+                <a:spcPts val="0"/>
+              </a:spcBef>
+              <a:spcAft>
+                <a:spcPts val="0"/>
+              </a:spcAft>
+            </a:pPr>
+            <a:r>
+              <a:rPr sz="1350" b="1" i="0">
+                <a:solidFill>
+                  <a:srgbClr val="2EC4B6"/>
+                </a:solidFill>
+                <a:latin typeface="Microsoft JhengHei"/>
+                <a:ea typeface="Microsoft JhengHei"/>
+                <a:cs typeface="Microsoft JhengHei"/>
+              </a:rPr>
+              <a:t>→ </a:t>
+            </a:r>
+            <a:r>
+              <a:rPr sz="1350" b="1" i="0">
+                <a:solidFill>
+                  <a:srgbClr val="0A2540"/>
+                </a:solidFill>
+                <a:latin typeface="Microsoft JhengHei"/>
+                <a:ea typeface="Microsoft JhengHei"/>
+                <a:cs typeface="Microsoft JhengHei"/>
+              </a:rPr>
+              <a:t>loss 一定用 CIoU 家族</a:t>
+            </a:r>
+            <a:r>
+              <a:rPr sz="1350" b="0" i="0">
+                <a:solidFill>
+                  <a:srgbClr val="1A2733"/>
+                </a:solidFill>
+                <a:latin typeface="Microsoft JhengHei"/>
+                <a:ea typeface="Microsoft JhengHei"/>
+                <a:cs typeface="Microsoft JhengHei"/>
+              </a:rPr>
+              <a:t>（要梯度）；</a:t>
+            </a:r>
+            <a:r>
+              <a:rPr sz="1350" b="1" i="0">
+                <a:solidFill>
+                  <a:srgbClr val="0A2540"/>
+                </a:solidFill>
+                <a:latin typeface="Microsoft JhengHei"/>
+                <a:ea typeface="Microsoft JhengHei"/>
+                <a:cs typeface="Microsoft JhengHei"/>
+              </a:rPr>
+              <a:t>mAP / NMS 一定用純 IoU</a:t>
+            </a:r>
+            <a:r>
+              <a:rPr sz="1350" b="0" i="0">
+                <a:solidFill>
+                  <a:srgbClr val="1A2733"/>
+                </a:solidFill>
+                <a:latin typeface="Microsoft JhengHei"/>
+                <a:ea typeface="Microsoft JhengHei"/>
+                <a:cs typeface="Microsoft JhengHei"/>
+              </a:rPr>
+              <a:t>（要跟論文公平比較）</a:t>
+            </a:r>
+          </a:p>
+        </p:txBody>
+      </p:sp>
+    </p:spTree>
+  </p:cSld>
+  <p:clrMapOvr>
+    <a:masterClrMapping/>
+  </p:clrMapOvr>
+</p:sld>
+</file>
+
+<file path=ppt/slides/slide11.xml><?xml version="1.0" encoding="utf-8"?>
 <p:sld xmlns:a="http://schemas.openxmlformats.org/drawingml/2006/main" xmlns:p="http://schemas.openxmlformats.org/presentationml/2006/main" xmlns:r="http://schemas.openxmlformats.org/officeDocument/2006/relationships">
   <p:cSld>
     <p:bg>

</xml_diff>